<commit_message>
fixed some things in the rpeort and ppt
</commit_message>
<xml_diff>
--- a/docs/Healthcare_Analytics_Presentation_with_Charts.pptx
+++ b/docs/Healthcare_Analytics_Presentation_with_Charts.pptx
@@ -15,7 +15,7 @@
     <p:sldId id="263" r:id="rId9"/>
     <p:sldId id="264" r:id="rId10"/>
     <p:sldId id="265" r:id="rId11"/>
-    <p:sldId id="266" r:id="rId17"/>
+    <p:sldId id="266" r:id="rId12"/>
   </p:sldIdLst>
   <p:sldSz cx="12188825" cy="6858000"/>
   <p:notesSz cx="6858000" cy="9144000"/>
@@ -3301,7 +3301,7 @@
           <a:p>
             <a:pPr algn="ctr"/>
             <a:r>
-              <a:rPr sz="3600" b="1" i="0">
+              <a:rPr sz="3600" b="1" i="0" dirty="0">
                 <a:solidFill>
                   <a:srgbClr val="FFFFFF"/>
                 </a:solidFill>
@@ -3354,28 +3354,65 @@
         <p:spPr>
           <a:xfrm>
             <a:off x="548640" y="2651760"/>
-            <a:ext cx="11064240" cy="502920"/>
-          </a:xfrm>
-          <a:prstGeom prst="rect">
-            <a:avLst/>
-          </a:prstGeom>
-          <a:noFill/>
-        </p:spPr>
-        <p:txBody>
-          <a:bodyPr wrap="square">
-            <a:spAutoFit/>
-          </a:bodyPr>
-          <a:lstStyle/>
-          <a:p>
-            <a:pPr algn="ctr"/>
-            <a:r>
-              <a:rPr sz="2000" b="1" i="0">
+            <a:ext cx="11064240" cy="400110"/>
+          </a:xfrm>
+          <a:prstGeom prst="rect">
+            <a:avLst/>
+          </a:prstGeom>
+          <a:noFill/>
+        </p:spPr>
+        <p:txBody>
+          <a:bodyPr wrap="square">
+            <a:spAutoFit/>
+          </a:bodyPr>
+          <a:lstStyle/>
+          <a:p>
+            <a:pPr algn="ctr"/>
+            <a:r>
+              <a:rPr lang="en-US" sz="2000" b="1" i="0" dirty="0">
                 <a:solidFill>
                   <a:srgbClr val="FFFFFF"/>
                 </a:solidFill>
               </a:rPr>
-              <a:t>Youssif Zaghloul  •  Kazzy</a:t>
-            </a:r>
+              <a:t>Khaled Mohamed </a:t>
+            </a:r>
+            <a:r>
+              <a:rPr sz="2000" b="1" i="0" dirty="0">
+                <a:solidFill>
+                  <a:srgbClr val="FFFFFF"/>
+                </a:solidFill>
+              </a:rPr>
+              <a:t>•  </a:t>
+            </a:r>
+            <a:r>
+              <a:rPr lang="en-US" sz="2000" b="1" i="0" dirty="0">
+                <a:solidFill>
+                  <a:srgbClr val="FFFFFF"/>
+                </a:solidFill>
+              </a:rPr>
+              <a:t>Mohamed </a:t>
+            </a:r>
+            <a:r>
+              <a:rPr lang="en-US" sz="2000" b="1" i="0" dirty="0" err="1">
+                <a:solidFill>
+                  <a:srgbClr val="FFFFFF"/>
+                </a:solidFill>
+              </a:rPr>
+              <a:t>ElKassas</a:t>
+            </a:r>
+            <a:r>
+              <a:rPr lang="en-US" sz="2000" b="1" dirty="0">
+                <a:solidFill>
+                  <a:srgbClr val="FFFFFF"/>
+                </a:solidFill>
+              </a:rPr>
+              <a:t> • Youssef Hassan • Mustafa Tantawy </a:t>
+            </a:r>
+            <a:endParaRPr sz="2000" b="1" i="0" dirty="0">
+              <a:solidFill>
+                <a:srgbClr val="FFFFFF"/>
+              </a:solidFill>
+            </a:endParaRPr>
           </a:p>
         </p:txBody>
       </p:sp>
@@ -4500,7 +4537,7 @@
           <p:nvPr/>
         </p:nvPicPr>
         <p:blipFill>
-          <a:blip r:embed="rId10"/>
+          <a:blip r:embed="rId2"/>
           <a:stretch>
             <a:fillRect/>
           </a:stretch>
@@ -4524,7 +4561,7 @@
           <p:nvPr/>
         </p:nvPicPr>
         <p:blipFill>
-          <a:blip r:embed="rId11"/>
+          <a:blip r:embed="rId3"/>
           <a:stretch>
             <a:fillRect/>
           </a:stretch>
@@ -4548,7 +4585,7 @@
           <p:nvPr/>
         </p:nvPicPr>
         <p:blipFill>
-          <a:blip r:embed="rId12"/>
+          <a:blip r:embed="rId4"/>
           <a:stretch>
             <a:fillRect/>
           </a:stretch>
@@ -4572,7 +4609,7 @@
           <p:nvPr/>
         </p:nvPicPr>
         <p:blipFill>
-          <a:blip r:embed="rId13"/>
+          <a:blip r:embed="rId5"/>
           <a:stretch>
             <a:fillRect/>
           </a:stretch>
@@ -4649,6 +4686,9 @@
       </p:sp>
     </p:spTree>
   </p:cSld>
+  <p:clrMapOvr>
+    <a:masterClrMapping/>
+  </p:clrMapOvr>
 </p:sld>
 </file>
 
@@ -4677,7 +4717,7 @@
         </p:nvSpPr>
         <p:spPr>
           <a:xfrm>
-            <a:off x="0" y="0"/>
+            <a:off x="0" y="5862"/>
             <a:ext cx="12188952" cy="6858000"/>
           </a:xfrm>
           <a:prstGeom prst="rect">
@@ -4765,7 +4805,7 @@
         </p:nvSpPr>
         <p:spPr>
           <a:xfrm>
-            <a:off x="320040" y="109728"/>
+            <a:off x="320040" y="124545"/>
             <a:ext cx="11247120" cy="685800"/>
           </a:xfrm>
           <a:prstGeom prst="rect">
@@ -5003,7 +5043,7 @@
         </p:nvSpPr>
         <p:spPr>
           <a:xfrm>
-            <a:off x="502920" y="1691640"/>
+            <a:off x="502920" y="1700107"/>
             <a:ext cx="5212080" cy="4389120"/>
           </a:xfrm>
           <a:prstGeom prst="rect">
@@ -5105,7 +5145,7 @@
         <p:spPr>
           <a:xfrm>
             <a:off x="6537960" y="1691640"/>
-            <a:ext cx="5212080" cy="4389120"/>
+            <a:ext cx="5212080" cy="2246769"/>
           </a:xfrm>
           <a:prstGeom prst="rect">
             <a:avLst/>
@@ -5120,18 +5160,34 @@
           <a:p>
             <a:pPr algn="l"/>
             <a:r>
-              <a:rPr sz="1400">
+              <a:rPr sz="1400" dirty="0">
                 <a:solidFill>
                   <a:srgbClr val="1A1A2E"/>
                 </a:solidFill>
               </a:rPr>
-              <a:t>• Ingest openFDA Drug Adverse Event records in near real-time via Apache Kafka</a:t>
+              <a:t>• Ingest </a:t>
+            </a:r>
+            <a:r>
+              <a:rPr sz="1400" dirty="0" err="1">
+                <a:solidFill>
+                  <a:srgbClr val="1A1A2E"/>
+                </a:solidFill>
+              </a:rPr>
+              <a:t>openFDA</a:t>
+            </a:r>
+            <a:r>
+              <a:rPr sz="1400" dirty="0">
+                <a:solidFill>
+                  <a:srgbClr val="1A1A2E"/>
+                </a:solidFill>
+              </a:rPr>
+              <a:t> Drug Adverse Event records in near real-time via Apache Kafka</a:t>
             </a:r>
           </a:p>
           <a:p>
             <a:pPr algn="l"/>
             <a:r>
-              <a:rPr sz="1400">
+              <a:rPr sz="1400" dirty="0">
                 <a:solidFill>
                   <a:srgbClr val="1A1A2E"/>
                 </a:solidFill>
@@ -5142,35 +5198,128 @@
           <a:p>
             <a:pPr algn="l"/>
             <a:r>
-              <a:rPr sz="1400">
+              <a:rPr sz="1400" dirty="0">
                 <a:solidFill>
                   <a:srgbClr val="1A1A2E"/>
                 </a:solidFill>
               </a:rPr>
-              <a:t>• Apply Spark MLlib risk classification to 7,573+ records</a:t>
+              <a:t>• Apply Spark </a:t>
+            </a:r>
+            <a:r>
+              <a:rPr sz="1400" dirty="0" err="1">
+                <a:solidFill>
+                  <a:srgbClr val="1A1A2E"/>
+                </a:solidFill>
+              </a:rPr>
+              <a:t>MLlib</a:t>
+            </a:r>
+            <a:r>
+              <a:rPr sz="1400" dirty="0">
+                <a:solidFill>
+                  <a:srgbClr val="1A1A2E"/>
+                </a:solidFill>
+              </a:rPr>
+              <a:t> risk classification to 7,573+ records</a:t>
             </a:r>
           </a:p>
           <a:p>
             <a:pPr algn="l"/>
             <a:r>
-              <a:rPr sz="1400">
+              <a:rPr sz="1400" dirty="0">
                 <a:solidFill>
                   <a:srgbClr val="1A1A2E"/>
                 </a:solidFill>
               </a:rPr>
-              <a:t>• Surface insights via PostgreSQL + Metabase dashboards</a:t>
+              <a:t>• Surface insights via PostgreSQL + </a:t>
+            </a:r>
+            <a:r>
+              <a:rPr sz="1400" dirty="0" err="1">
+                <a:solidFill>
+                  <a:srgbClr val="1A1A2E"/>
+                </a:solidFill>
+              </a:rPr>
+              <a:t>Metabase</a:t>
+            </a:r>
+            <a:r>
+              <a:rPr sz="1400" dirty="0">
+                <a:solidFill>
+                  <a:srgbClr val="1A1A2E"/>
+                </a:solidFill>
+              </a:rPr>
+              <a:t> dashboards</a:t>
             </a:r>
           </a:p>
           <a:p>
             <a:pPr algn="l"/>
             <a:r>
-              <a:rPr sz="1400">
+              <a:rPr sz="1400" dirty="0">
                 <a:solidFill>
                   <a:srgbClr val="1A1A2E"/>
                 </a:solidFill>
               </a:rPr>
-              <a:t>• Fully containerised — runs with a single docker compose up</a:t>
-            </a:r>
+              <a:t>• Fully </a:t>
+            </a:r>
+            <a:r>
+              <a:rPr sz="1400" dirty="0" err="1">
+                <a:solidFill>
+                  <a:srgbClr val="1A1A2E"/>
+                </a:solidFill>
+              </a:rPr>
+              <a:t>containerised</a:t>
+            </a:r>
+            <a:r>
+              <a:rPr sz="1400" dirty="0">
+                <a:solidFill>
+                  <a:srgbClr val="1A1A2E"/>
+                </a:solidFill>
+              </a:rPr>
+              <a:t> — runs with a single docker compose up</a:t>
+            </a:r>
+            <a:endParaRPr lang="en-US" sz="1400" dirty="0">
+              <a:solidFill>
+                <a:srgbClr val="1A1A2E"/>
+              </a:solidFill>
+            </a:endParaRPr>
+          </a:p>
+          <a:p>
+            <a:pPr algn="l"/>
+            <a:endParaRPr lang="en-US" sz="1400" dirty="0">
+              <a:solidFill>
+                <a:srgbClr val="1A1A2E"/>
+              </a:solidFill>
+            </a:endParaRPr>
+          </a:p>
+          <a:p>
+            <a:pPr algn="l"/>
+            <a:endParaRPr lang="en-US" sz="1400" dirty="0">
+              <a:solidFill>
+                <a:srgbClr val="1A1A2E"/>
+              </a:solidFill>
+            </a:endParaRPr>
+          </a:p>
+          <a:p>
+            <a:pPr algn="l"/>
+            <a:endParaRPr lang="en-US" sz="1400" dirty="0">
+              <a:solidFill>
+                <a:srgbClr val="1A1A2E"/>
+              </a:solidFill>
+            </a:endParaRPr>
+          </a:p>
+          <a:p>
+            <a:pPr algn="ctr"/>
+            <a:r>
+              <a:rPr lang="en-US" sz="1400" dirty="0">
+                <a:solidFill>
+                  <a:srgbClr val="1A1A2E"/>
+                </a:solidFill>
+              </a:rPr>
+              <a:t>Top 10 reported reactions bar chart</a:t>
+            </a:r>
+            <a:endParaRPr sz="1400" dirty="0">
+              <a:solidFill>
+                <a:srgbClr val="1A1A2E"/>
+              </a:solidFill>
+            </a:endParaRPr>
           </a:p>
         </p:txBody>
       </p:sp>
@@ -5295,21 +5444,56 @@
           <p:nvPr/>
         </p:nvPicPr>
         <p:blipFill>
-          <a:blip r:embed="rId10"/>
+          <a:blip r:embed="rId2"/>
           <a:stretch>
             <a:fillRect/>
           </a:stretch>
         </p:blipFill>
         <p:spPr>
           <a:xfrm>
-            <a:off x="6400000" y="1300000"/>
-            <a:ext cx="5500000" cy="2800000"/>
+            <a:off x="6355080" y="3497072"/>
+            <a:ext cx="5434330" cy="2766568"/>
           </a:xfrm>
           <a:prstGeom prst="rect">
             <a:avLst/>
           </a:prstGeom>
         </p:spPr>
       </p:pic>
+      <p:sp>
+        <p:nvSpPr>
+          <p:cNvPr id="17" name="TextBox 16">
+            <a:extLst>
+              <a:ext uri="{FF2B5EF4-FFF2-40B4-BE49-F238E27FC236}">
+                <a16:creationId xmlns:a16="http://schemas.microsoft.com/office/drawing/2014/main" id="{8461CF60-AEE9-5925-8C90-02798D2FB0FF}"/>
+              </a:ext>
+            </a:extLst>
+          </p:cNvPr>
+          <p:cNvSpPr txBox="1"/>
+          <p:nvPr/>
+        </p:nvSpPr>
+        <p:spPr>
+          <a:xfrm>
+            <a:off x="7385421" y="3715381"/>
+            <a:ext cx="4986411" cy="369332"/>
+          </a:xfrm>
+          <a:prstGeom prst="rect">
+            <a:avLst/>
+          </a:prstGeom>
+          <a:noFill/>
+        </p:spPr>
+        <p:txBody>
+          <a:bodyPr wrap="square">
+            <a:spAutoFit/>
+          </a:bodyPr>
+          <a:lstStyle/>
+          <a:p>
+            <a:r>
+              <a:rPr lang="en-US" dirty="0"/>
+              <a:t>Top 10 reported reactions</a:t>
+            </a:r>
+          </a:p>
+        </p:txBody>
+      </p:sp>
     </p:spTree>
   </p:cSld>
   <p:clrMapOvr>
@@ -5465,7 +5649,7 @@
         </p:nvSpPr>
         <p:spPr>
           <a:xfrm>
-            <a:off x="320040" y="713232"/>
+            <a:off x="308927" y="722376"/>
             <a:ext cx="11247120" cy="320040"/>
           </a:xfrm>
           <a:prstGeom prst="rect">
@@ -5481,12 +5665,12 @@
           <a:p>
             <a:pPr algn="l"/>
             <a:r>
-              <a:rPr sz="1400" b="0" i="0">
+              <a:rPr sz="1400" b="0" i="0" dirty="0">
                 <a:solidFill>
                   <a:srgbClr val="F5A623"/>
                 </a:solidFill>
               </a:rPr>
-              <a:t>SMART goals aligned with the CSCI461 rubric</a:t>
+              <a:t>SMART goals</a:t>
             </a:r>
           </a:p>
         </p:txBody>
@@ -6448,7 +6632,7 @@
         </p:nvSpPr>
         <p:spPr>
           <a:xfrm>
-            <a:off x="0" y="0"/>
+            <a:off x="0" y="12212"/>
             <a:ext cx="12188952" cy="6858000"/>
           </a:xfrm>
           <a:prstGeom prst="rect">
@@ -6480,7 +6664,11 @@
           <a:lstStyle/>
           <a:p>
             <a:pPr algn="ctr"/>
-            <a:endParaRPr/>
+            <a:r>
+              <a:rPr lang="en-US" dirty="0"/>
+              <a:t>symptoms analysis bar chart</a:t>
+            </a:r>
+            <a:endParaRPr dirty="0"/>
           </a:p>
         </p:txBody>
       </p:sp>
@@ -6694,7 +6882,7 @@
         </p:nvSpPr>
         <p:spPr>
           <a:xfrm>
-            <a:off x="502920" y="1298448"/>
+            <a:off x="502920" y="1292098"/>
             <a:ext cx="4937760" cy="411480"/>
           </a:xfrm>
           <a:prstGeom prst="rect">
@@ -6744,7 +6932,7 @@
           <a:p>
             <a:pPr algn="l"/>
             <a:r>
-              <a:rPr sz="1350">
+              <a:rPr sz="1350" dirty="0">
                 <a:solidFill>
                   <a:srgbClr val="1A1A2E"/>
                 </a:solidFill>
@@ -6755,18 +6943,34 @@
           <a:p>
             <a:pPr algn="l"/>
             <a:r>
-              <a:rPr sz="1350">
+              <a:rPr sz="1350" dirty="0">
                 <a:solidFill>
                   <a:srgbClr val="1A1A2E"/>
                 </a:solidFill>
               </a:rPr>
-              <a:t>• Access: openFDA drug/event REST API (no key required)</a:t>
+              <a:t>• Access: </a:t>
+            </a:r>
+            <a:r>
+              <a:rPr sz="1350" dirty="0" err="1">
+                <a:solidFill>
+                  <a:srgbClr val="1A1A2E"/>
+                </a:solidFill>
+              </a:rPr>
+              <a:t>openFDA</a:t>
+            </a:r>
+            <a:r>
+              <a:rPr sz="1350" dirty="0">
+                <a:solidFill>
+                  <a:srgbClr val="1A1A2E"/>
+                </a:solidFill>
+              </a:rPr>
+              <a:t> drug/event REST API (no key required)</a:t>
             </a:r>
           </a:p>
           <a:p>
             <a:pPr algn="l"/>
             <a:r>
-              <a:rPr sz="1350">
+              <a:rPr sz="1350" dirty="0">
                 <a:solidFill>
                   <a:srgbClr val="1A1A2E"/>
                 </a:solidFill>
@@ -6777,7 +6981,7 @@
           <a:p>
             <a:pPr algn="l"/>
             <a:r>
-              <a:rPr sz="1350">
+              <a:rPr sz="1350" dirty="0">
                 <a:solidFill>
                   <a:srgbClr val="1A1A2E"/>
                 </a:solidFill>
@@ -6788,18 +6992,34 @@
           <a:p>
             <a:pPr algn="l"/>
             <a:r>
-              <a:rPr sz="1350">
+              <a:rPr sz="1350" dirty="0">
                 <a:solidFill>
                   <a:srgbClr val="1A1A2E"/>
                 </a:solidFill>
               </a:rPr>
-              <a:t>• Fields used: patient age, weight, sex; drug name; reaction MedDRA term; seriousness flags (death, hospitalisation); receipt date</a:t>
+              <a:t>• Fields used: patient age, weight, sex; drug name; reaction MedDRA term; seriousness flags (death, </a:t>
+            </a:r>
+            <a:r>
+              <a:rPr sz="1350" dirty="0" err="1">
+                <a:solidFill>
+                  <a:srgbClr val="1A1A2E"/>
+                </a:solidFill>
+              </a:rPr>
+              <a:t>hospitalisation</a:t>
+            </a:r>
+            <a:r>
+              <a:rPr sz="1350" dirty="0">
+                <a:solidFill>
+                  <a:srgbClr val="1A1A2E"/>
+                </a:solidFill>
+              </a:rPr>
+              <a:t>); receipt date</a:t>
             </a:r>
           </a:p>
           <a:p>
             <a:pPr algn="l"/>
             <a:r>
-              <a:rPr sz="1350">
+              <a:rPr sz="1350" dirty="0">
                 <a:solidFill>
                   <a:srgbClr val="1A1A2E"/>
                 </a:solidFill>
@@ -7919,7 +8139,7 @@
           <a:p>
             <a:pPr algn="l"/>
             <a:r>
-              <a:rPr sz="1200" b="0" i="0">
+              <a:rPr sz="1200" b="0" i="0" dirty="0">
                 <a:solidFill>
                   <a:srgbClr val="1A1A2E"/>
                 </a:solidFill>
@@ -8210,15 +8430,15 @@
           <p:nvPr/>
         </p:nvPicPr>
         <p:blipFill>
-          <a:blip r:embed="rId10"/>
+          <a:blip r:embed="rId2"/>
           <a:stretch>
             <a:fillRect/>
           </a:stretch>
         </p:blipFill>
         <p:spPr>
           <a:xfrm>
-            <a:off x="6300000" y="1400000"/>
-            <a:ext cx="5600000" cy="3000000"/>
+            <a:off x="325071" y="3520456"/>
+            <a:ext cx="5298489" cy="2743184"/>
           </a:xfrm>
           <a:prstGeom prst="rect">
             <a:avLst/>
@@ -8234,21 +8454,91 @@
           <p:nvPr/>
         </p:nvPicPr>
         <p:blipFill>
-          <a:blip r:embed="rId11"/>
+          <a:blip r:embed="rId3"/>
           <a:stretch>
             <a:fillRect/>
           </a:stretch>
         </p:blipFill>
         <p:spPr>
           <a:xfrm>
-            <a:off x="6300000" y="4700000"/>
-            <a:ext cx="5600000" cy="1900000"/>
+            <a:off x="6183922" y="4461862"/>
+            <a:ext cx="5703277" cy="1783489"/>
           </a:xfrm>
           <a:prstGeom prst="rect">
             <a:avLst/>
           </a:prstGeom>
         </p:spPr>
       </p:pic>
+      <p:sp>
+        <p:nvSpPr>
+          <p:cNvPr id="48" name="TextBox 47">
+            <a:extLst>
+              <a:ext uri="{FF2B5EF4-FFF2-40B4-BE49-F238E27FC236}">
+                <a16:creationId xmlns:a16="http://schemas.microsoft.com/office/drawing/2014/main" id="{844E32E7-76BB-2B69-469E-D7C5940F7706}"/>
+              </a:ext>
+            </a:extLst>
+          </p:cNvPr>
+          <p:cNvSpPr txBox="1"/>
+          <p:nvPr/>
+        </p:nvSpPr>
+        <p:spPr>
+          <a:xfrm>
+            <a:off x="6126480" y="4476987"/>
+            <a:ext cx="6140450" cy="369332"/>
+          </a:xfrm>
+          <a:prstGeom prst="rect">
+            <a:avLst/>
+          </a:prstGeom>
+          <a:noFill/>
+        </p:spPr>
+        <p:txBody>
+          <a:bodyPr wrap="square">
+            <a:spAutoFit/>
+          </a:bodyPr>
+          <a:lstStyle/>
+          <a:p>
+            <a:r>
+              <a:rPr lang="en-US" dirty="0"/>
+              <a:t>symptoms analysis</a:t>
+            </a:r>
+          </a:p>
+        </p:txBody>
+      </p:sp>
+      <p:sp>
+        <p:nvSpPr>
+          <p:cNvPr id="50" name="TextBox 49">
+            <a:extLst>
+              <a:ext uri="{FF2B5EF4-FFF2-40B4-BE49-F238E27FC236}">
+                <a16:creationId xmlns:a16="http://schemas.microsoft.com/office/drawing/2014/main" id="{BB3D7B76-8AC2-ECB6-7410-9A637B6C15D2}"/>
+              </a:ext>
+            </a:extLst>
+          </p:cNvPr>
+          <p:cNvSpPr txBox="1"/>
+          <p:nvPr/>
+        </p:nvSpPr>
+        <p:spPr>
+          <a:xfrm>
+            <a:off x="842963" y="3479029"/>
+            <a:ext cx="6156324" cy="369332"/>
+          </a:xfrm>
+          <a:prstGeom prst="rect">
+            <a:avLst/>
+          </a:prstGeom>
+          <a:noFill/>
+        </p:spPr>
+        <p:txBody>
+          <a:bodyPr wrap="square">
+            <a:spAutoFit/>
+          </a:bodyPr>
+          <a:lstStyle/>
+          <a:p>
+            <a:r>
+              <a:rPr lang="en-US" dirty="0"/>
+              <a:t>Reports over time by receipt date</a:t>
+            </a:r>
+          </a:p>
+        </p:txBody>
+      </p:sp>
     </p:spTree>
   </p:cSld>
   <p:clrMapOvr>
@@ -10945,7 +11235,7 @@
         </p:nvSpPr>
         <p:spPr>
           <a:xfrm>
-            <a:off x="0" y="0"/>
+            <a:off x="0" y="6350"/>
             <a:ext cx="12188952" cy="6858000"/>
           </a:xfrm>
           <a:prstGeom prst="rect">
@@ -11033,7 +11323,7 @@
         </p:nvSpPr>
         <p:spPr>
           <a:xfrm>
-            <a:off x="320040" y="109728"/>
+            <a:off x="320040" y="116078"/>
             <a:ext cx="11247120" cy="685800"/>
           </a:xfrm>
           <a:prstGeom prst="rect">
@@ -11083,13 +11373,26 @@
           <a:p>
             <a:pPr algn="l"/>
             <a:r>
-              <a:rPr sz="1400" b="0" i="0">
+              <a:rPr sz="1400" b="0" i="0" dirty="0">
                 <a:solidFill>
                   <a:srgbClr val="F5A623"/>
                 </a:solidFill>
               </a:rPr>
-              <a:t>Feature engineering + three-model comparison using Spark MLlib</a:t>
-            </a:r>
+              <a:t>Feature engineering + three-model comparison using Spark </a:t>
+            </a:r>
+            <a:r>
+              <a:rPr sz="1400" b="0" i="0" dirty="0" err="1">
+                <a:solidFill>
+                  <a:srgbClr val="F5A623"/>
+                </a:solidFill>
+              </a:rPr>
+              <a:t>MLlib</a:t>
+            </a:r>
+            <a:endParaRPr sz="1400" b="0" i="0" dirty="0">
+              <a:solidFill>
+                <a:srgbClr val="F5A623"/>
+              </a:solidFill>
+            </a:endParaRPr>
           </a:p>
         </p:txBody>
       </p:sp>
@@ -11911,7 +12214,7 @@
         </p:nvSpPr>
         <p:spPr>
           <a:xfrm>
-            <a:off x="3694176" y="2907791"/>
+            <a:off x="3664269" y="2833370"/>
             <a:ext cx="1847088" cy="585216"/>
           </a:xfrm>
           <a:prstGeom prst="rect">
@@ -11927,13 +12230,66 @@
           <a:p>
             <a:pPr algn="l"/>
             <a:r>
-              <a:rPr sz="1050" b="0" i="0">
+              <a:rPr sz="1050" b="0" i="0" dirty="0" err="1">
                 <a:solidFill>
                   <a:srgbClr val="1A1A2E"/>
                 </a:solidFill>
               </a:rPr>
-              <a:t>StringIndexer (handleInvalid=keep) → OneHotEncoder → VectorAssembler</a:t>
-            </a:r>
+              <a:t>StringIndexer</a:t>
+            </a:r>
+            <a:r>
+              <a:rPr sz="1050" b="0" i="0" dirty="0">
+                <a:solidFill>
+                  <a:srgbClr val="1A1A2E"/>
+                </a:solidFill>
+              </a:rPr>
+              <a:t> (</a:t>
+            </a:r>
+            <a:r>
+              <a:rPr sz="1050" b="0" i="0" dirty="0" err="1">
+                <a:solidFill>
+                  <a:srgbClr val="1A1A2E"/>
+                </a:solidFill>
+              </a:rPr>
+              <a:t>handleInvalid</a:t>
+            </a:r>
+            <a:r>
+              <a:rPr sz="1050" b="0" i="0" dirty="0">
+                <a:solidFill>
+                  <a:srgbClr val="1A1A2E"/>
+                </a:solidFill>
+              </a:rPr>
+              <a:t>=keep) → </a:t>
+            </a:r>
+            <a:r>
+              <a:rPr sz="1050" b="0" i="0" dirty="0" err="1">
+                <a:solidFill>
+                  <a:srgbClr val="1A1A2E"/>
+                </a:solidFill>
+              </a:rPr>
+              <a:t>OneHotEncoder</a:t>
+            </a:r>
+            <a:r>
+              <a:rPr sz="1050" b="0" i="0" dirty="0">
+                <a:solidFill>
+                  <a:srgbClr val="1A1A2E"/>
+                </a:solidFill>
+              </a:rPr>
+              <a:t> → </a:t>
+            </a:r>
+            <a:r>
+              <a:rPr sz="1050" b="0" i="0" dirty="0" err="1">
+                <a:solidFill>
+                  <a:srgbClr val="1A1A2E"/>
+                </a:solidFill>
+              </a:rPr>
+              <a:t>VectorAssembler</a:t>
+            </a:r>
+            <a:endParaRPr sz="1050" b="0" i="0" dirty="0">
+              <a:solidFill>
+                <a:srgbClr val="1A1A2E"/>
+              </a:solidFill>
+            </a:endParaRPr>
           </a:p>
         </p:txBody>
       </p:sp>
@@ -12333,7 +12689,7 @@
         </p:nvSpPr>
         <p:spPr>
           <a:xfrm>
-            <a:off x="530225" y="4087368"/>
+            <a:off x="410087" y="4112006"/>
             <a:ext cx="4572000" cy="384048"/>
           </a:xfrm>
           <a:prstGeom prst="rect">
@@ -12388,7 +12744,7 @@
                   <a:srgbClr val="1A1A2E"/>
                 </a:solidFill>
               </a:rPr>
-              <a:t xml:space="preserve">F1 balances precision and recall — critical in healthcare where both false positives (unnecessary clinical alerts) and false negatives (missed serious events) carry real costs. Evaluation via Spark </a:t>
+              <a:t>F1 balances precision and recall — critical in healthcare where both false positives (unnecessary clinical alerts) and false negatives (missed serious events) carry real costs. Evaluation via Spark </a:t>
             </a:r>
             <a:r>
               <a:rPr sz="1250" b="0" i="0" dirty="0" err="1">
@@ -12404,7 +12760,7 @@
                   <a:srgbClr val="1A1A2E"/>
                 </a:solidFill>
               </a:rPr>
-              <a:t xml:space="preserve"> on an 80/20 train-test split.</a:t>
+              <a:t> on an 80/20 train-test split.</a:t>
             </a:r>
           </a:p>
         </p:txBody>

</xml_diff>